<commit_message>
Fix invalid paragraph properties that made PowerPoint repair decks
Co-Authored-By: Claude Opus 5.5 <noreply@anthropic.com>
Claude-Session: https://claude.ai/code/session_017Y6u7rCbRQ9PkzBKGjkCLX
</commit_message>
<xml_diff>
--- a/presentaciones/Estrategia_Comercial_2027.pptx
+++ b/presentaciones/Estrategia_Comercial_2027.pptx
@@ -112,7 +112,7 @@
   <p:extLst>
     <p:ext uri="{521415D9-36F7-43E2-AB2F-B90AF26B5E84}">
       <p14:sectionLst xmlns:p14="http://schemas.microsoft.com/office/powerpoint/2010/main">
-        <p14:section name="Estrategia comercial" id="{f6f5e94b-74bd-508e-6536-6e4586927397}">
+        <p14:section name="Estrategia comercial" id="{de74277f-bdea-2bf5-e58f-906921bbbca3}">
           <p14:sldIdLst>
             <p14:sldId id="256"/>
             <p14:sldId id="257"/>
@@ -1706,9 +1706,6 @@
               </a:rPr>
               <a:t>#SOMOS</a:t>
             </a:r>
-            <a:pPr indent="0" marL="0">
-              <a:buNone/>
-            </a:pPr>
             <a:r>
               <a:rPr lang="en-US" sz="1700" b="1" dirty="0">
                 <a:solidFill>
@@ -2082,9 +2079,6 @@
               </a:rPr>
               <a:t>#SOMOS</a:t>
             </a:r>
-            <a:pPr indent="0" marL="0">
-              <a:buNone/>
-            </a:pPr>
             <a:r>
               <a:rPr lang="en-US" sz="2000" b="1" dirty="0">
                 <a:solidFill>
@@ -2270,9 +2264,6 @@
               </a:rPr>
               <a:t>PISO 1  </a:t>
             </a:r>
-            <a:pPr indent="0" marL="0">
-              <a:buNone/>
-            </a:pPr>
             <a:r>
               <a:rPr lang="en-US" sz="1700" b="1" dirty="0">
                 <a:solidFill>
@@ -2417,9 +2408,6 @@
               </a:rPr>
               <a:t>PISO 2  </a:t>
             </a:r>
-            <a:pPr indent="0" marL="0">
-              <a:buNone/>
-            </a:pPr>
             <a:r>
               <a:rPr lang="en-US" sz="1700" b="1" dirty="0">
                 <a:solidFill>
@@ -2564,9 +2552,6 @@
               </a:rPr>
               <a:t>PISO 3  </a:t>
             </a:r>
-            <a:pPr indent="0" marL="0">
-              <a:buNone/>
-            </a:pPr>
             <a:r>
               <a:rPr lang="en-US" sz="1700" b="1" dirty="0">
                 <a:solidFill>
@@ -2700,9 +2685,6 @@
             <a:pPr indent="0" marL="0">
               <a:buNone/>
             </a:pPr>
-            <a:pPr indent="0" marL="0">
-              <a:buNone/>
-            </a:pPr>
             <a:r>
               <a:rPr lang="en-US" sz="1700" b="1" dirty="0">
                 <a:solidFill>
@@ -2714,7 +2696,7 @@
               </a:rPr>
               <a:t>INSCRITOS</a:t>
             </a:r>
-            <a:endParaRPr lang="en-US" sz="1050" dirty="0"/>
+            <a:endParaRPr lang="en-US" sz="1700" dirty="0"/>
           </a:p>
         </p:txBody>
       </p:sp>
@@ -5456,9 +5438,6 @@
               </a:rPr>
               <a:t>#SOMOS</a:t>
             </a:r>
-            <a:pPr indent="0" marL="0">
-              <a:buNone/>
-            </a:pPr>
             <a:r>
               <a:rPr lang="en-US" sz="2000" b="1" dirty="0">
                 <a:solidFill>
@@ -6045,9 +6024,6 @@
               </a:rPr>
               <a:t>Objetivo: </a:t>
             </a:r>
-            <a:pPr indent="0" marL="0">
-              <a:buNone/>
-            </a:pPr>
             <a:r>
               <a:rPr lang="en-US" sz="1500" dirty="0">
                 <a:solidFill>
@@ -8206,9 +8182,6 @@
               </a:rPr>
               <a:t>#SOMOS</a:t>
             </a:r>
-            <a:pPr indent="0" marL="0">
-              <a:buNone/>
-            </a:pPr>
             <a:r>
               <a:rPr lang="en-US" sz="2000" b="1" dirty="0">
                 <a:solidFill>
@@ -10273,9 +10246,6 @@
               </a:rPr>
               <a:t>#SOMOS</a:t>
             </a:r>
-            <a:pPr indent="0" marL="0">
-              <a:buNone/>
-            </a:pPr>
             <a:r>
               <a:rPr lang="en-US" sz="2000" b="1" dirty="0">
                 <a:solidFill>
@@ -11104,9 +11074,6 @@
               </a:rPr>
               <a:t>Visitas a Universidad: </a:t>
             </a:r>
-            <a:pPr indent="0" marL="0">
-              <a:buNone/>
-            </a:pPr>
             <a:r>
               <a:rPr lang="en-US" sz="1150" dirty="0">
                 <a:solidFill>
@@ -11157,9 +11124,6 @@
               </a:rPr>
               <a:t>Resultado: </a:t>
             </a:r>
-            <a:pPr indent="0" marL="0">
-              <a:buNone/>
-            </a:pPr>
             <a:r>
               <a:rPr lang="en-US" sz="1150" b="1" i="1" dirty="0">
                 <a:solidFill>
@@ -13971,9 +13935,6 @@
               </a:rPr>
               <a:t>#SOMOS</a:t>
             </a:r>
-            <a:pPr indent="0" marL="0">
-              <a:buNone/>
-            </a:pPr>
             <a:r>
               <a:rPr lang="en-US" sz="2000" b="1" dirty="0">
                 <a:solidFill>
@@ -14386,9 +14347,6 @@
               </a:rPr>
               <a:t>Para ampliar las fuentes de prospectos, se está trabajando en un programa de </a:t>
             </a:r>
-            <a:pPr indent="0" marL="0">
-              <a:buNone/>
-            </a:pPr>
             <a:r>
               <a:rPr lang="en-US" sz="1500" b="1" dirty="0">
                 <a:solidFill>
@@ -14400,9 +14358,6 @@
               </a:rPr>
               <a:t>10 empresas</a:t>
             </a:r>
-            <a:pPr indent="0" marL="0">
-              <a:buNone/>
-            </a:pPr>
             <a:r>
               <a:rPr lang="en-US" sz="1500" dirty="0">
                 <a:solidFill>

</xml_diff>